<commit_message>
docs: sync product docs with GitHub Pages (4/13 discussion)
- Flow → Process throughout all docs
- Four layer descriptions aligned with index.html
- Pain points rewritten: grouped by Build/Train/Process, P-numbers removed
- Build: added shared knowledge space (Agent 版飞书文档/Wiki)
- Train: emphasize agent self-learning, scene-triggered recall, slogan alignment
- Process: human-defined process, system-enforced, kill switch as fallback
- Orchestration Layer Chinese label: 项目管理 → 流程管控
- PRD: removed Discord reference from subtitle
- Pitch deck: regenerated PPTX with all updates, renamed to hybrid-workspace-pitch.pptx
</commit_message>
<xml_diff>
--- a/product/hybrid-workspace-pitch.pptx
+++ b/product/hybrid-workspace-pitch.pptx
@@ -3432,7 +3432,7 @@
               </a:defRPr>
             </a:pPr>
             <a:r>
-              <a:t>contact@hybridworkforce.ai  ·  hybridworkforce.ai</a:t>
+              <a:t>contact@hybridworkspace.ai  ·  hybridworkspace.ai</a:t>
             </a:r>
           </a:p>
         </p:txBody>
@@ -3778,7 +3778,7 @@
                 </a:solidFill>
                 <a:latin typeface="Calibri"/>
               </a:rPr>
-              <a:t>没有组织架构</a:t>
+              <a:t>Build 的痛：组建团队难</a:t>
             </a:r>
           </a:p>
           <a:p>
@@ -3791,7 +3791,7 @@
               </a:defRPr>
             </a:pPr>
             <a:r>
-              <a:t>谁做什么、向谁汇报？</a:t>
+              <a:t>一个 agent 不够用，新 agent 又上手慢</a:t>
             </a:r>
           </a:p>
         </p:txBody>
@@ -3827,15 +3827,19 @@
               </a:defRPr>
             </a:pPr>
             <a:r>
-              <a:t>· PM 和 QA 都有验收职责，边界模糊，PM 看 QA 卡住就帮忙绕过</a:t>
+              <a:t>· 一个 Agent 跨多项目，context 和 bandwidth 不够用，性能下降</a:t>
             </a:r>
             <a:br/>
             <a:r>
-              <a:t>· PM 被冻结期间仍越界帮 QA 推文件、贴 issue</a:t>
+              <a:t>· 新 Agent 即使有 onboarding skill，实际项目中仍需反复沟通</a:t>
             </a:r>
             <a:br/>
             <a:r>
-              <a:t>· Dev 没等需求评审就开工，PR 做完才发现方向错了</a:t>
+              <a:t>· 没有共享知识空间，项目决策和经验散落在各自 session 中</a:t>
+            </a:r>
+            <a:br/>
+            <a:r>
+              <a:t>· 谁在做什么、卡在哪里，管理者无处可看</a:t>
             </a:r>
           </a:p>
         </p:txBody>
@@ -3912,7 +3916,7 @@
                 </a:solidFill>
                 <a:latin typeface="Calibri"/>
               </a:rPr>
-              <a:t>没有组织记忆</a:t>
+              <a:t>Train 的痛：教了记不住</a:t>
             </a:r>
           </a:p>
           <a:p>
@@ -3925,7 +3929,7 @@
               </a:defRPr>
             </a:pPr>
             <a:r>
-              <a:t>昨天的决策今天忘了</a:t>
+              <a:t>Teach Once, Store Forever, Recall Never</a:t>
             </a:r>
           </a:p>
         </p:txBody>
@@ -3961,19 +3965,19 @@
               </a:defRPr>
             </a:pPr>
             <a:r>
-              <a:t>· 连续 5 天无 daily notes，项目状态完全失明</a:t>
+              <a:t>· Skill 里写了「GitHub issue 图片用 markdown 格式」，但每次都忘</a:t>
             </a:r>
             <a:br/>
             <a:r>
-              <a:t>· PR #101 验收停在 22%，无人知道是卡住还是被遗忘</a:t>
+              <a:t>· 规则不是没有，是在 20+ 条中被上下文稀释——Agent 不会「触景生情」</a:t>
             </a:r>
             <a:br/>
             <a:r>
-              <a:t>· PM→QA 交接丢失决策上下文，实现违反 PRD 决策</a:t>
+              <a:t>· 同一条规则纠正多次，跨 session 后又忘</a:t>
             </a:r>
             <a:br/>
             <a:r>
-              <a:t>· 验收只看最近 PR，漏掉累积改动，通过后 bug 更多</a:t>
+              <a:t>· 一个 Agent 学到的教训，同角色其他 Agent 不知道</a:t>
             </a:r>
           </a:p>
         </p:txBody>
@@ -4050,7 +4054,7 @@
                 </a:solidFill>
                 <a:latin typeface="Calibri"/>
               </a:rPr>
-              <a:t>存储 ≠ 召回</a:t>
+              <a:t>Process 的痛：流程形同虚设</a:t>
             </a:r>
           </a:p>
           <a:p>
@@ -4063,7 +4067,7 @@
               </a:defRPr>
             </a:pPr>
             <a:r>
-              <a:t>Teach Once, Store Forever, Recall Never</a:t>
+              <a:t>有规定没执行，人类失控</a:t>
             </a:r>
           </a:p>
         </p:txBody>
@@ -4099,157 +4103,19 @@
               </a:defRPr>
             </a:pPr>
             <a:r>
-              <a:t>· Manta 的 Skill 里写了「GitHub issue 图片用 markdown 格式」，但每次都忘，需要反复提醒</a:t>
+              <a:t>· QA 没写 test case 就验收，没截图就报 Pass</a:t>
             </a:r>
             <a:br/>
             <a:r>
-              <a:t>· 规则不是没有，是在 20+ 条中被上下文稀释——Agent 不会像人一样「触景生情」</a:t>
+              <a:t>· Bug 和需求变更混着处理，该写 PRD 的直接开干</a:t>
             </a:r>
             <a:br/>
             <a:r>
-              <a:t>· 同一条规则纠正多次，跨 session 后又忘了，每个新 session 从零开始</a:t>
+              <a:t>· 关键节点不等人类审批，Agent 自作主张往下走</a:t>
             </a:r>
             <a:br/>
             <a:r>
-              <a:t>· 新 QA 加入当天：端口用错、流程不会、用代码审查代替实际运行</a:t>
-            </a:r>
-          </a:p>
-        </p:txBody>
-      </p:sp>
-      <p:sp>
-        <p:nvSpPr>
-          <p:cNvPr id="13" name="Rectangle 12"/>
-          <p:cNvSpPr/>
-          <p:nvPr/>
-        </p:nvSpPr>
-        <p:spPr>
-          <a:xfrm>
-            <a:off x="914400" y="5596128"/>
-            <a:ext cx="10515600" cy="3657"/>
-          </a:xfrm>
-          <a:prstGeom prst="rect">
-            <a:avLst/>
-          </a:prstGeom>
-          <a:solidFill>
-            <a:srgbClr val="6C5CE7"/>
-          </a:solidFill>
-          <a:ln>
-            <a:noFill/>
-          </a:ln>
-        </p:spPr>
-        <p:style>
-          <a:lnRef idx="1">
-            <a:schemeClr val="accent1"/>
-          </a:lnRef>
-          <a:fillRef idx="3">
-            <a:schemeClr val="accent1"/>
-          </a:fillRef>
-          <a:effectRef idx="2">
-            <a:schemeClr val="accent1"/>
-          </a:effectRef>
-          <a:fontRef idx="minor">
-            <a:schemeClr val="lt1"/>
-          </a:fontRef>
-        </p:style>
-        <p:txBody>
-          <a:bodyPr rtlCol="0" anchor="ctr"/>
-          <a:lstStyle/>
-          <a:p>
-            <a:pPr algn="ctr"/>
-          </a:p>
-        </p:txBody>
-      </p:sp>
-      <p:sp>
-        <p:nvSpPr>
-          <p:cNvPr id="14" name="TextBox 13"/>
-          <p:cNvSpPr txBox="1"/>
-          <p:nvPr/>
-        </p:nvSpPr>
-        <p:spPr>
-          <a:xfrm>
-            <a:off x="914400" y="5669280"/>
-            <a:ext cx="4114800" cy="822960"/>
-          </a:xfrm>
-          <a:prstGeom prst="rect">
-            <a:avLst/>
-          </a:prstGeom>
-          <a:noFill/>
-        </p:spPr>
-        <p:txBody>
-          <a:bodyPr wrap="square">
-            <a:spAutoFit/>
-          </a:bodyPr>
-          <a:lstStyle/>
-          <a:p>
-            <a:r>
-              <a:rPr sz="1800" b="1">
-                <a:solidFill>
-                  <a:srgbClr val="6C5CE7"/>
-                </a:solidFill>
-                <a:latin typeface="Calibri"/>
-              </a:rPr>
-              <a:t>没有流程规范</a:t>
-            </a:r>
-          </a:p>
-          <a:p>
-            <a:pPr>
-              <a:defRPr sz="1300">
-                <a:solidFill>
-                  <a:srgbClr val="C8C8D2"/>
-                </a:solidFill>
-                <a:latin typeface="Calibri"/>
-              </a:defRPr>
-            </a:pPr>
-            <a:r>
-              <a:t>AI 自作主张，人类失控</a:t>
-            </a:r>
-          </a:p>
-        </p:txBody>
-      </p:sp>
-      <p:sp>
-        <p:nvSpPr>
-          <p:cNvPr id="15" name="TextBox 14"/>
-          <p:cNvSpPr txBox="1"/>
-          <p:nvPr/>
-        </p:nvSpPr>
-        <p:spPr>
-          <a:xfrm>
-            <a:off x="5486400" y="5669280"/>
-            <a:ext cx="5943600" cy="868680"/>
-          </a:xfrm>
-          <a:prstGeom prst="rect">
-            <a:avLst/>
-          </a:prstGeom>
-          <a:noFill/>
-        </p:spPr>
-        <p:txBody>
-          <a:bodyPr wrap="square">
-            <a:spAutoFit/>
-          </a:bodyPr>
-          <a:lstStyle/>
-          <a:p>
-            <a:pPr algn="l">
-              <a:defRPr sz="1100" b="0">
-                <a:solidFill>
-                  <a:srgbClr val="828296"/>
-                </a:solidFill>
-                <a:latin typeface="Calibri"/>
-              </a:defRPr>
-            </a:pPr>
-            <a:r>
-              <a:t>· QA 没有截图就报验收 Pass，团队基于假结果做决策</a:t>
-            </a:r>
-            <a:br/>
-            <a:r>
-              <a:t>· Agent 跑长任务时变成聋子，叫停指令等 2 小时才读到</a:t>
-            </a:r>
-            <a:br/>
-            <a:r>
-              <a:t>· 跑完错误任务后刷屏输出，淹没其他人的消息</a:t>
-            </a:r>
-            <a:br/>
-            <a:r>
-              <a:t>· 后端路径用错导致 LLM 走 fallback，整个上午验收结果不可靠</a:t>
+              <a:t>· 人类说「停」，Agent 跑长任务时完全听不到</a:t>
             </a:r>
           </a:p>
         </p:txBody>
@@ -4649,7 +4515,7 @@
               </a:defRPr>
             </a:pPr>
             <a:r>
-              <a:t>行为准则、权限边界</a:t>
+              <a:t>角色模板自带技能、规则与行为边界，上岗即守规矩</a:t>
             </a:r>
           </a:p>
         </p:txBody>
@@ -4802,7 +4668,7 @@
               </a:defRPr>
             </a:pPr>
             <a:r>
-              <a:t>决策记录、经验沉淀</a:t>
+              <a:t>决策、经验、上下文跨 Agent 持久传承，关键时刻主动推送</a:t>
             </a:r>
           </a:p>
         </p:txBody>
@@ -4955,7 +4821,7 @@
               </a:defRPr>
             </a:pPr>
             <a:r>
-              <a:t>纠正→规则→进化</a:t>
+              <a:t>从项目经历与人类反馈中自主学习，纠正自动沉淀为规则</a:t>
             </a:r>
           </a:p>
         </p:txBody>
@@ -5072,7 +4938,7 @@
               </a:defRPr>
             </a:pPr>
             <a:r>
-              <a:t>项目管理</a:t>
+              <a:t>流程管控</a:t>
             </a:r>
           </a:p>
         </p:txBody>
@@ -5108,7 +4974,7 @@
               </a:defRPr>
             </a:pPr>
             <a:r>
-              <a:t>碳硅分工、流程调度</a:t>
+              <a:t>人类定义流程，系统强制执行，跳步即拦截</a:t>
             </a:r>
           </a:p>
         </p:txBody>
@@ -5249,7 +5115,7 @@
                 </a:solidFill>
                 <a:latin typeface="Calibri"/>
               </a:rPr>
-              <a:t>— 一键拉起 PM + Dev + QA</a:t>
+              <a:t>— 一键拉起 PM + Dev + QA，自带角色技能与行为边界</a:t>
             </a:r>
           </a:p>
         </p:txBody>
@@ -5283,7 +5149,7 @@
                 </a:solidFill>
                 <a:latin typeface="Calibri"/>
               </a:rPr>
-              <a:t>角色定义 </a:t>
+              <a:t>共享知识空间 </a:t>
             </a:r>
             <a:r>
               <a:rPr sz="2000">
@@ -5292,7 +5158,7 @@
                 </a:solidFill>
                 <a:latin typeface="Calibri"/>
               </a:rPr>
-              <a:t>— 每个 Agent 有身份、准则、技能</a:t>
+              <a:t>— 项目 PRD、决策记录、踩坑经验统一沉淀，Agent 版的飞书文档 / Wiki</a:t>
             </a:r>
           </a:p>
         </p:txBody>
@@ -5326,7 +5192,7 @@
                 </a:solidFill>
                 <a:latin typeface="Calibri"/>
               </a:rPr>
-              <a:t>共享知识库 </a:t>
+              <a:t>组织记忆传承 </a:t>
             </a:r>
             <a:r>
               <a:rPr sz="2000">
@@ -5335,7 +5201,7 @@
                 </a:solidFill>
                 <a:latin typeface="Calibri"/>
               </a:rPr>
-              <a:t>— 团队共享上下文，不重复交代</a:t>
+              <a:t>— 新 Agent 加入即继承项目上下文，不从零开始反复沟通</a:t>
             </a:r>
           </a:p>
         </p:txBody>
@@ -5371,7 +5237,7 @@
               </a:defRPr>
             </a:pPr>
             <a:r>
-              <a:t>30 分钟从零到开始干活</a:t>
+              <a:t>有人有家，30 分钟从零到开始干活</a:t>
             </a:r>
           </a:p>
         </p:txBody>
@@ -5588,7 +5454,7 @@
               </a:defRPr>
             </a:pPr>
             <a:r>
-              <a:t>▸  你说一句话 → 每个 Agent 自己识别相关规则 → 写入行为准则</a:t>
+              <a:t>▸  Agent 从项目经历与人类反馈中自主学习，纠正自动沉淀为规则</a:t>
             </a:r>
           </a:p>
         </p:txBody>
@@ -5624,7 +5490,7 @@
               </a:defRPr>
             </a:pPr>
             <a:r>
-              <a:t>▸  四层记忆保障：场景触发 / 行为前检查 / 失败记忆召回 / 渐进式强化</a:t>
+              <a:t>▸  规则来源：人类纠正 + Agent 自我学习，都过人类审批</a:t>
             </a:r>
           </a:p>
         </p:txBody>
@@ -5765,7 +5631,7 @@
               </a:defRPr>
             </a:pPr>
             <a:r>
-              <a:t>Orchestrate Human-AI Workflows</a:t>
+              <a:t>Process — 人类定义流程，Agent 必须遵守</a:t>
             </a:r>
           </a:p>
         </p:txBody>
@@ -5799,7 +5665,7 @@
                 </a:solidFill>
                 <a:latin typeface="Calibri"/>
               </a:rPr>
-              <a:t>自然语言定义流程 </a:t>
+              <a:t>人类定义流程 </a:t>
             </a:r>
             <a:r>
               <a:rPr sz="2000">
@@ -5808,7 +5674,7 @@
                 </a:solidFill>
                 <a:latin typeface="Calibri"/>
               </a:rPr>
-              <a:t>— 说一遍，Agent 各自领会并执行</a:t>
+              <a:t>— QA 验收前必须写 test case、验收后必须出报告带截图</a:t>
             </a:r>
           </a:p>
         </p:txBody>
@@ -5842,7 +5708,7 @@
                 </a:solidFill>
                 <a:latin typeface="Calibri"/>
               </a:rPr>
-              <a:t>Human Gate </a:t>
+              <a:t>区分 bug 和需求变更 </a:t>
             </a:r>
             <a:r>
               <a:rPr sz="2000">
@@ -5851,7 +5717,7 @@
                 </a:solidFill>
                 <a:latin typeface="Calibri"/>
               </a:rPr>
-              <a:t>— 关键决策必须人类拍板</a:t>
+              <a:t>— 不同问题走不同流程，需求变更需要 PRD 评审</a:t>
             </a:r>
           </a:p>
         </p:txBody>
@@ -5885,7 +5751,7 @@
                 </a:solidFill>
                 <a:latin typeface="Calibri"/>
               </a:rPr>
-              <a:t>Kill Switch </a:t>
+              <a:t>流程强制执行 </a:t>
             </a:r>
             <a:r>
               <a:rPr sz="2000">
@@ -5894,7 +5760,7 @@
                 </a:solidFill>
                 <a:latin typeface="Calibri"/>
               </a:rPr>
-              <a:t>— 实时中断，人类永远掌控</a:t>
+              <a:t>— Agent 试图跳步，系统自动拦截</a:t>
             </a:r>
           </a:p>
         </p:txBody>
@@ -5928,7 +5794,7 @@
                 </a:solidFill>
                 <a:latin typeface="Calibri"/>
               </a:rPr>
-              <a:t>Live Monitor </a:t>
+              <a:t>Kill Switch </a:t>
             </a:r>
             <a:r>
               <a:rPr sz="2000">
@@ -5937,7 +5803,7 @@
                 </a:solidFill>
                 <a:latin typeface="Calibri"/>
               </a:rPr>
-              <a:t>— 随时知道 AI 在做什么</a:t>
+              <a:t>— 万一拦截没拦住，人类随时强制打断（兜底）</a:t>
             </a:r>
           </a:p>
         </p:txBody>

</xml_diff>